<commit_message>
sd-02-020: quiz asks per-run gain, not frequency; sparse checkout and shallow clone kept apart
Co-Authored-By: Claude Opus 5.5 <noreply@anthropic.com>
Claude-Session: https://claude.ai/code/session_01McBLtMnJbTnB94NeVs8a2V
</commit_message>
<xml_diff>
--- a/system-design-101/vi/lessons/sd-02-020/slides/sd-02-020.pptx
+++ b/system-design-101/vi/lessons/sd-02-020/slides/sd-02-020.pptx
@@ -11686,7 +11686,7 @@
               <a:t> nhất,</a:t>
             </a:r>
             <a:r>
-              <a:rPr lang="en-US" sz="6600" dirty="0" spc="0" kern="0">
+              <a:rPr lang="en-US" sz="6600" dirty="0" spc="-71" kern="0">
                 <a:solidFill>
                   <a:srgbClr val="F3EEE3"/>
                 </a:solidFill>
@@ -11694,10 +11694,10 @@
                 <a:ea typeface="Bricolage Grotesque ExtraBold" pitchFamily="34" charset="-122"/>
                 <a:cs typeface="Bricolage Grotesque ExtraBold" pitchFamily="34" charset="-120"/>
               </a:rPr>
-              <a:t> hay</a:t>
-            </a:r>
-            <a:r>
-              <a:rPr lang="en-US" sz="6600" dirty="0" spc="-2" kern="0">
+              <a:t> và</a:t>
+            </a:r>
+            <a:r>
+              <a:rPr lang="en-US" sz="6600" dirty="0" spc="-33" kern="0">
                 <a:solidFill>
                   <a:srgbClr val="F3EEE3"/>
                 </a:solidFill>
@@ -11705,10 +11705,10 @@
                 <a:ea typeface="Bricolage Grotesque ExtraBold" pitchFamily="34" charset="-122"/>
                 <a:cs typeface="Bricolage Grotesque ExtraBold" pitchFamily="34" charset="-120"/>
               </a:rPr>
-              <a:t> chạy</a:t>
-            </a:r>
-            <a:r>
-              <a:rPr lang="en-US" sz="6600" dirty="0" spc="1" kern="0">
+              <a:t> lợi</a:t>
+            </a:r>
+            <a:r>
+              <a:rPr lang="en-US" sz="6600" dirty="0" spc="-1" kern="0">
                 <a:solidFill>
                   <a:srgbClr val="F3EEE3"/>
                 </a:solidFill>
@@ -11716,10 +11716,10 @@
                 <a:ea typeface="Bricolage Grotesque ExtraBold" pitchFamily="34" charset="-122"/>
                 <a:cs typeface="Bricolage Grotesque ExtraBold" pitchFamily="34" charset="-120"/>
               </a:rPr>
-              <a:t> nhiều</a:t>
-            </a:r>
-            <a:r>
-              <a:rPr lang="en-US" sz="6600" dirty="0" spc="-1" kern="0">
+              <a:t> nhất</a:t>
+            </a:r>
+            <a:r>
+              <a:rPr lang="en-US" sz="6600" dirty="0" spc="1" kern="0">
                 <a:solidFill>
                   <a:srgbClr val="F3EEE3"/>
                 </a:solidFill>
@@ -11727,7 +11727,18 @@
                 <a:ea typeface="Bricolage Grotesque ExtraBold" pitchFamily="34" charset="-122"/>
                 <a:cs typeface="Bricolage Grotesque ExtraBold" pitchFamily="34" charset="-120"/>
               </a:rPr>
-              <a:t> nhất?</a:t>
+              <a:t> mỗi</a:t>
+            </a:r>
+            <a:r>
+              <a:rPr lang="en-US" sz="6600" dirty="0" spc="-22" kern="0">
+                <a:solidFill>
+                  <a:srgbClr val="F3EEE3"/>
+                </a:solidFill>
+                <a:latin typeface="Bricolage Grotesque ExtraBold" pitchFamily="34" charset="0"/>
+                <a:ea typeface="Bricolage Grotesque ExtraBold" pitchFamily="34" charset="-122"/>
+                <a:cs typeface="Bricolage Grotesque ExtraBold" pitchFamily="34" charset="-120"/>
+              </a:rPr>
+              <a:t> lần?</a:t>
             </a:r>
             <a:endParaRPr lang="en-US" sz="6600" dirty="0"/>
           </a:p>
@@ -12001,7 +12012,7 @@
               <a:buNone/>
             </a:pPr>
             <a:r>
-              <a:rPr lang="en-US" sz="1800" b="1" spc="224" kern="0" dirty="0">
+              <a:rPr lang="en-US" sz="1800" b="1" spc="196" kern="0" dirty="0">
                 <a:solidFill>
                   <a:srgbClr val="9AA0B5"/>
                 </a:solidFill>
@@ -12009,10 +12020,10 @@
                 <a:ea typeface="Be Vietnam Pro" pitchFamily="34" charset="-122"/>
                 <a:cs typeface="Be Vietnam Pro" pitchFamily="34" charset="-120"/>
               </a:rPr>
-              <a:t>MỖI</a:t>
-            </a:r>
-            <a:r>
-              <a:rPr lang="en-US" sz="1800" b="1" spc="190" kern="0" dirty="0">
+              <a:t>LỢI</a:t>
+            </a:r>
+            <a:r>
+              <a:rPr lang="en-US" sz="1800" b="1" spc="188" kern="0" dirty="0">
                 <a:solidFill>
                   <a:srgbClr val="9AA0B5"/>
                 </a:solidFill>
@@ -12020,10 +12031,10 @@
                 <a:ea typeface="Be Vietnam Pro" pitchFamily="34" charset="-122"/>
                 <a:cs typeface="Be Vietnam Pro" pitchFamily="34" charset="-120"/>
               </a:rPr>
-              <a:t> NGÀY</a:t>
-            </a:r>
-            <a:r>
-              <a:rPr lang="en-US" sz="1800" b="1" spc="224" kern="0" dirty="0">
+              <a:t> NHẤT</a:t>
+            </a:r>
+            <a:r>
+              <a:rPr lang="en-US" sz="1800" b="1" spc="225" kern="0" dirty="0">
                 <a:solidFill>
                   <a:srgbClr val="9AA0B5"/>
                 </a:solidFill>
@@ -12034,6 +12045,17 @@
               <a:t> ·</a:t>
             </a:r>
             <a:r>
+              <a:rPr lang="en-US" sz="1800" b="1" spc="223" kern="0" dirty="0">
+                <a:solidFill>
+                  <a:srgbClr val="9AA0B5"/>
+                </a:solidFill>
+                <a:latin typeface="Be Vietnam Pro" pitchFamily="34" charset="0"/>
+                <a:ea typeface="Be Vietnam Pro" pitchFamily="34" charset="-122"/>
+                <a:cs typeface="Be Vietnam Pro" pitchFamily="34" charset="-120"/>
+              </a:rPr>
+              <a:t> GẤP</a:t>
+            </a:r>
+            <a:r>
               <a:rPr lang="en-US" sz="1800" b="1" spc="226" kern="0" dirty="0">
                 <a:solidFill>
                   <a:srgbClr val="9AA0B5"/>
@@ -12042,18 +12064,7 @@
                 <a:ea typeface="Be Vietnam Pro" pitchFamily="34" charset="-122"/>
                 <a:cs typeface="Be Vietnam Pro" pitchFamily="34" charset="-120"/>
               </a:rPr>
-              <a:t> NHIỀU</a:t>
-            </a:r>
-            <a:r>
-              <a:rPr lang="en-US" sz="1800" b="1" spc="223" kern="0" dirty="0">
-                <a:solidFill>
-                  <a:srgbClr val="9AA0B5"/>
-                </a:solidFill>
-                <a:latin typeface="Be Vietnam Pro" pitchFamily="34" charset="0"/>
-                <a:ea typeface="Be Vietnam Pro" pitchFamily="34" charset="-122"/>
-                <a:cs typeface="Be Vietnam Pro" pitchFamily="34" charset="-120"/>
-              </a:rPr>
-              <a:t> LẦN</a:t>
+              <a:t> 7</a:t>
             </a:r>
             <a:endParaRPr lang="en-US" sz="1800" dirty="0"/>
           </a:p>
@@ -12233,6 +12244,17 @@
               <a:buNone/>
             </a:pPr>
             <a:r>
+              <a:rPr lang="en-US" sz="1800" b="1" spc="196" kern="0" dirty="0">
+                <a:solidFill>
+                  <a:srgbClr val="9AA0B5"/>
+                </a:solidFill>
+                <a:latin typeface="Be Vietnam Pro" pitchFamily="34" charset="0"/>
+                <a:ea typeface="Be Vietnam Pro" pitchFamily="34" charset="-122"/>
+                <a:cs typeface="Be Vietnam Pro" pitchFamily="34" charset="-120"/>
+              </a:rPr>
+              <a:t>LỢI</a:t>
+            </a:r>
+            <a:r>
               <a:rPr lang="en-US" sz="1800" b="1" spc="224" kern="0" dirty="0">
                 <a:solidFill>
                   <a:srgbClr val="9AA0B5"/>
@@ -12241,10 +12263,10 @@
                 <a:ea typeface="Be Vietnam Pro" pitchFamily="34" charset="-122"/>
                 <a:cs typeface="Be Vietnam Pro" pitchFamily="34" charset="-120"/>
               </a:rPr>
-              <a:t>MỖI</a:t>
-            </a:r>
-            <a:r>
-              <a:rPr lang="en-US" sz="1800" b="1" spc="190" kern="0" dirty="0">
+              <a:t> ÍT</a:t>
+            </a:r>
+            <a:r>
+              <a:rPr lang="en-US" sz="1800" b="1" spc="188" kern="0" dirty="0">
                 <a:solidFill>
                   <a:srgbClr val="9AA0B5"/>
                 </a:solidFill>
@@ -12252,40 +12274,7 @@
                 <a:ea typeface="Be Vietnam Pro" pitchFamily="34" charset="-122"/>
                 <a:cs typeface="Be Vietnam Pro" pitchFamily="34" charset="-120"/>
               </a:rPr>
-              <a:t> NGÀY</a:t>
-            </a:r>
-            <a:r>
-              <a:rPr lang="en-US" sz="1800" b="1" spc="224" kern="0" dirty="0">
-                <a:solidFill>
-                  <a:srgbClr val="9AA0B5"/>
-                </a:solidFill>
-                <a:latin typeface="Be Vietnam Pro" pitchFamily="34" charset="0"/>
-                <a:ea typeface="Be Vietnam Pro" pitchFamily="34" charset="-122"/>
-                <a:cs typeface="Be Vietnam Pro" pitchFamily="34" charset="-120"/>
-              </a:rPr>
-              <a:t> ·</a:t>
-            </a:r>
-            <a:r>
-              <a:rPr lang="en-US" sz="1800" b="1" spc="226" kern="0" dirty="0">
-                <a:solidFill>
-                  <a:srgbClr val="9AA0B5"/>
-                </a:solidFill>
-                <a:latin typeface="Be Vietnam Pro" pitchFamily="34" charset="0"/>
-                <a:ea typeface="Be Vietnam Pro" pitchFamily="34" charset="-122"/>
-                <a:cs typeface="Be Vietnam Pro" pitchFamily="34" charset="-120"/>
-              </a:rPr>
-              <a:t> NHIỀU</a:t>
-            </a:r>
-            <a:r>
-              <a:rPr lang="en-US" sz="1800" b="1" spc="223" kern="0" dirty="0">
-                <a:solidFill>
-                  <a:srgbClr val="9AA0B5"/>
-                </a:solidFill>
-                <a:latin typeface="Be Vietnam Pro" pitchFamily="34" charset="0"/>
-                <a:ea typeface="Be Vietnam Pro" pitchFamily="34" charset="-122"/>
-                <a:cs typeface="Be Vietnam Pro" pitchFamily="34" charset="-120"/>
-              </a:rPr>
-              <a:t> LẦN</a:t>
+              <a:t> NHẤT</a:t>
             </a:r>
             <a:endParaRPr lang="en-US" sz="1800" dirty="0"/>
           </a:p>
@@ -12405,7 +12394,7 @@
               <a:buNone/>
             </a:pPr>
             <a:r>
-              <a:rPr lang="en-US" sz="2550" dirty="0" spc="-38" kern="0">
+              <a:rPr lang="en-US" sz="2550" dirty="0" spc="2" kern="0">
                 <a:solidFill>
                   <a:srgbClr val="C4C8D6"/>
                 </a:solidFill>
@@ -12413,10 +12402,10 @@
                 <a:ea typeface="Be Vietnam Pro" pitchFamily="34" charset="-122"/>
                 <a:cs typeface="Be Vietnam Pro" pitchFamily="34" charset="-120"/>
               </a:rPr>
-              <a:t>Vài</a:t>
-            </a:r>
-            <a:r>
-              <a:rPr lang="en-US" sz="2550" dirty="0" spc="-7" kern="0">
+              <a:t>Bảng</a:t>
+            </a:r>
+            <a:r>
+              <a:rPr lang="en-US" sz="2550" dirty="0" spc="1" kern="0">
                 <a:solidFill>
                   <a:srgbClr val="C4C8D6"/>
                 </a:solidFill>
@@ -12424,7 +12413,18 @@
                 <a:ea typeface="Be Vietnam Pro" pitchFamily="34" charset="-122"/>
                 <a:cs typeface="Be Vietnam Pro" pitchFamily="34" charset="-120"/>
               </a:rPr>
-              <a:t> giây</a:t>
+              <a:t> chỉ</a:t>
+            </a:r>
+            <a:r>
+              <a:rPr lang="en-US" sz="2550" dirty="0" spc="0" kern="0">
+                <a:solidFill>
+                  <a:srgbClr val="C4C8D6"/>
+                </a:solidFill>
+                <a:latin typeface="Be Vietnam Pro" pitchFamily="34" charset="0"/>
+                <a:ea typeface="Be Vietnam Pro" pitchFamily="34" charset="-122"/>
+                <a:cs typeface="Be Vietnam Pro" pitchFamily="34" charset="-120"/>
+              </a:rPr>
+              <a:t> cho thời</a:t>
             </a:r>
             <a:r>
               <a:rPr lang="en-US" sz="2550" dirty="0" spc="-1" kern="0">
@@ -12435,7 +12435,7 @@
                 <a:ea typeface="Be Vietnam Pro" pitchFamily="34" charset="-122"/>
                 <a:cs typeface="Be Vietnam Pro" pitchFamily="34" charset="-120"/>
               </a:rPr>
-              <a:t> mỗi</a:t>
+              <a:t> gian</a:t>
             </a:r>
             <a:r>
               <a:rPr lang="en-US" sz="2550" dirty="0" spc="0" kern="0">
@@ -12446,10 +12446,10 @@
                 <a:ea typeface="Be Vietnam Pro" pitchFamily="34" charset="-122"/>
                 <a:cs typeface="Be Vietnam Pro" pitchFamily="34" charset="-120"/>
               </a:rPr>
-              <a:t> lần,</a:t>
-            </a:r>
-            <a:r>
-              <a:rPr lang="en-US" sz="2550" dirty="0" spc="-8" kern="0">
+              <a:t> mỗi lần, không cho</a:t>
+            </a:r>
+            <a:r>
+              <a:rPr lang="en-US" sz="2550" dirty="0" spc="-11" kern="0">
                 <a:solidFill>
                   <a:srgbClr val="C4C8D6"/>
                 </a:solidFill>
@@ -12457,10 +12457,10 @@
                 <a:ea typeface="Be Vietnam Pro" pitchFamily="34" charset="-122"/>
                 <a:cs typeface="Be Vietnam Pro" pitchFamily="34" charset="-120"/>
               </a:rPr>
-              <a:t> chạy</a:t>
-            </a:r>
-            <a:r>
-              <a:rPr lang="en-US" sz="2550" dirty="0" spc="1" kern="0">
+              <a:t> số</a:t>
+            </a:r>
+            <a:r>
+              <a:rPr lang="en-US" sz="2550" dirty="0" spc="0" kern="0">
                 <a:solidFill>
                   <a:srgbClr val="C4C8D6"/>
                 </a:solidFill>
@@ -12468,10 +12468,10 @@
                 <a:ea typeface="Be Vietnam Pro" pitchFamily="34" charset="-122"/>
                 <a:cs typeface="Be Vietnam Pro" pitchFamily="34" charset="-120"/>
               </a:rPr>
-              <a:t> nhiều</a:t>
-            </a:r>
-            <a:r>
-              <a:rPr lang="en-US" sz="2550" dirty="0" spc="0" kern="0">
+              <a:t> lần</a:t>
+            </a:r>
+            <a:r>
+              <a:rPr lang="en-US" sz="2550" dirty="0" spc="-5" kern="0">
                 <a:solidFill>
                   <a:srgbClr val="C4C8D6"/>
                 </a:solidFill>
@@ -12479,40 +12479,7 @@
                 <a:ea typeface="Be Vietnam Pro" pitchFamily="34" charset="-122"/>
                 <a:cs typeface="Be Vietnam Pro" pitchFamily="34" charset="-120"/>
               </a:rPr>
-              <a:t> lần,</a:t>
-            </a:r>
-            <a:r>
-              <a:rPr lang="en-US" sz="2550" dirty="0" spc="-15" kern="0">
-                <a:solidFill>
-                  <a:srgbClr val="C4C8D6"/>
-                </a:solidFill>
-                <a:latin typeface="Be Vietnam Pro" pitchFamily="34" charset="0"/>
-                <a:ea typeface="Be Vietnam Pro" pitchFamily="34" charset="-122"/>
-                <a:cs typeface="Be Vietnam Pro" pitchFamily="34" charset="-120"/>
-              </a:rPr>
-              <a:t> vẫn</a:t>
-            </a:r>
-            <a:r>
-              <a:rPr lang="en-US" sz="2550" dirty="0" spc="0" kern="0">
-                <a:solidFill>
-                  <a:srgbClr val="C4C8D6"/>
-                </a:solidFill>
-                <a:latin typeface="Be Vietnam Pro" pitchFamily="34" charset="0"/>
-                <a:ea typeface="Be Vietnam Pro" pitchFamily="34" charset="-122"/>
-                <a:cs typeface="Be Vietnam Pro" pitchFamily="34" charset="-120"/>
-              </a:rPr>
-              <a:t> cộng</a:t>
-            </a:r>
-            <a:r>
-              <a:rPr lang="en-US" sz="2550" dirty="0" spc="1" kern="0">
-                <a:solidFill>
-                  <a:srgbClr val="C4C8D6"/>
-                </a:solidFill>
-                <a:latin typeface="Be Vietnam Pro" pitchFamily="34" charset="0"/>
-                <a:ea typeface="Be Vietnam Pro" pitchFamily="34" charset="-122"/>
-                <a:cs typeface="Be Vietnam Pro" pitchFamily="34" charset="-120"/>
-              </a:rPr>
-              <a:t> thành nhiều.</a:t>
+              <a:t> chạy.</a:t>
             </a:r>
             <a:endParaRPr lang="en-US" sz="2550" dirty="0"/>
           </a:p>
@@ -13586,10 +13553,10 @@
                 <a:ea typeface="Be Vietnam Pro" pitchFamily="34" charset="-122"/>
                 <a:cs typeface="Be Vietnam Pro" pitchFamily="34" charset="-120"/>
               </a:rPr>
-              <a:t> giảm: chỉ</a:t>
-            </a:r>
-            <a:r>
-              <a:rPr lang="en-US" sz="2700" dirty="0" spc="-11" kern="0">
+              <a:t> giảm:</a:t>
+            </a:r>
+            <a:r>
+              <a:rPr lang="en-US" sz="2700" dirty="0" spc="-8" kern="0">
                 <a:solidFill>
                   <a:srgbClr val="F3EEE3"/>
                 </a:solidFill>
@@ -13597,7 +13564,29 @@
                 <a:ea typeface="Be Vietnam Pro" pitchFamily="34" charset="-122"/>
                 <a:cs typeface="Be Vietnam Pro" pitchFamily="34" charset="-120"/>
               </a:rPr>
-              <a:t> lấy</a:t>
+              <a:t> sparse</a:t>
+            </a:r>
+            <a:r>
+              <a:rPr lang="en-US" sz="2700" dirty="0" spc="-12" kern="0">
+                <a:solidFill>
+                  <a:srgbClr val="F3EEE3"/>
+                </a:solidFill>
+                <a:latin typeface="Be Vietnam Pro" pitchFamily="34" charset="0"/>
+                <a:ea typeface="Be Vietnam Pro" pitchFamily="34" charset="-122"/>
+                <a:cs typeface="Be Vietnam Pro" pitchFamily="34" charset="-120"/>
+              </a:rPr>
+              <a:t> checkout;</a:t>
+            </a:r>
+            <a:r>
+              <a:rPr lang="en-US" sz="2700" dirty="0" spc="0" kern="0">
+                <a:solidFill>
+                  <a:srgbClr val="F3EEE3"/>
+                </a:solidFill>
+                <a:latin typeface="Be Vietnam Pro" pitchFamily="34" charset="0"/>
+                <a:ea typeface="Be Vietnam Pro" pitchFamily="34" charset="-122"/>
+                <a:cs typeface="Be Vietnam Pro" pitchFamily="34" charset="-120"/>
+              </a:rPr>
+              <a:t> clone</a:t>
             </a:r>
             <a:r>
               <a:rPr lang="en-US" sz="2700" dirty="0" spc="-2" kern="0">
@@ -13608,29 +13597,7 @@
                 <a:ea typeface="Be Vietnam Pro" pitchFamily="34" charset="-122"/>
                 <a:cs typeface="Be Vietnam Pro" pitchFamily="34" charset="-120"/>
               </a:rPr>
-              <a:t> phần</a:t>
-            </a:r>
-            <a:r>
-              <a:rPr lang="en-US" sz="2700" dirty="0" spc="1" kern="0">
-                <a:solidFill>
-                  <a:srgbClr val="F3EEE3"/>
-                </a:solidFill>
-                <a:latin typeface="Be Vietnam Pro" pitchFamily="34" charset="0"/>
-                <a:ea typeface="Be Vietnam Pro" pitchFamily="34" charset="-122"/>
-                <a:cs typeface="Be Vietnam Pro" pitchFamily="34" charset="-120"/>
-              </a:rPr>
-              <a:t> thư</a:t>
-            </a:r>
-            <a:r>
-              <a:rPr lang="en-US" sz="2700" dirty="0" spc="-1" kern="0">
-                <a:solidFill>
-                  <a:srgbClr val="F3EEE3"/>
-                </a:solidFill>
-                <a:latin typeface="Be Vietnam Pro" pitchFamily="34" charset="0"/>
-                <a:ea typeface="Be Vietnam Pro" pitchFamily="34" charset="-122"/>
-                <a:cs typeface="Be Vietnam Pro" pitchFamily="34" charset="-120"/>
-              </a:rPr>
-              <a:t> mục cần.</a:t>
+              <a:t> nông.</a:t>
             </a:r>
             <a:endParaRPr lang="en-US" sz="2700" dirty="0"/>
           </a:p>

</xml_diff>

<commit_message>
sd-02-020: full-history download is what a default clone does
Co-Authored-By: Claude Opus 5.5 <noreply@anthropic.com>
Claude-Session: https://claude.ai/code/session_01McBLtMnJbTnB94NeVs8a2V
</commit_message>
<xml_diff>
--- a/system-design-101/vi/lessons/sd-02-020/slides/sd-02-020.pptx
+++ b/system-design-101/vi/lessons/sd-02-020/slides/sd-02-020.pptx
@@ -13175,6 +13175,28 @@
               <a:t>clone</a:t>
             </a:r>
             <a:r>
+              <a:rPr lang="en-US" sz="2700" dirty="0" spc="0" kern="0">
+                <a:solidFill>
+                  <a:srgbClr val="14161C"/>
+                </a:solidFill>
+                <a:latin typeface="Be Vietnam Pro" pitchFamily="34" charset="0"/>
+                <a:ea typeface="Be Vietnam Pro" pitchFamily="34" charset="-122"/>
+                <a:cs typeface="Be Vietnam Pro" pitchFamily="34" charset="-120"/>
+              </a:rPr>
+              <a:t> mặc</a:t>
+            </a:r>
+            <a:r>
+              <a:rPr lang="en-US" sz="2700" dirty="0" spc="19" kern="0">
+                <a:solidFill>
+                  <a:srgbClr val="14161C"/>
+                </a:solidFill>
+                <a:latin typeface="Be Vietnam Pro" pitchFamily="34" charset="0"/>
+                <a:ea typeface="Be Vietnam Pro" pitchFamily="34" charset="-122"/>
+                <a:cs typeface="Be Vietnam Pro" pitchFamily="34" charset="-120"/>
+              </a:rPr>
+              <a:t> định</a:t>
+            </a:r>
+            <a:r>
               <a:rPr lang="en-US" sz="2700" dirty="0" spc="-13" kern="0">
                 <a:solidFill>
                   <a:srgbClr val="14161C"/>
@@ -13197,7 +13219,7 @@
               <a:t> mọi</a:t>
             </a:r>
             <a:r>
-              <a:rPr lang="en-US" sz="2700" dirty="0" spc="-15" kern="0">
+              <a:rPr lang="en-US" sz="2700" dirty="0" spc="-11" kern="0">
                 <a:solidFill>
                   <a:srgbClr val="14161C"/>
                 </a:solidFill>
@@ -13205,10 +13227,10 @@
                 <a:ea typeface="Be Vietnam Pro" pitchFamily="34" charset="-122"/>
                 <a:cs typeface="Be Vietnam Pro" pitchFamily="34" charset="-120"/>
               </a:rPr>
-              <a:t> tệp</a:t>
-            </a:r>
-            <a:r>
-              <a:rPr lang="en-US" sz="2700" dirty="0" spc="-17" kern="0">
+              <a:t> tệp,</a:t>
+            </a:r>
+            <a:r>
+              <a:rPr lang="en-US" sz="2700" dirty="0" spc="-14" kern="0">
                 <a:solidFill>
                   <a:srgbClr val="14161C"/>
                 </a:solidFill>
@@ -13216,10 +13238,10 @@
                 <a:ea typeface="Be Vietnam Pro" pitchFamily="34" charset="-122"/>
                 <a:cs typeface="Be Vietnam Pro" pitchFamily="34" charset="-120"/>
               </a:rPr>
-              <a:t> và</a:t>
-            </a:r>
-            <a:r>
-              <a:rPr lang="en-US" sz="2700" dirty="0" spc="-15" kern="0">
+              <a:t> toàn</a:t>
+            </a:r>
+            <a:r>
+              <a:rPr lang="en-US" sz="2700" dirty="0" spc="-8" kern="0">
                 <a:solidFill>
                   <a:srgbClr val="14161C"/>
                 </a:solidFill>
@@ -13227,10 +13249,10 @@
                 <a:ea typeface="Be Vietnam Pro" pitchFamily="34" charset="-122"/>
                 <a:cs typeface="Be Vietnam Pro" pitchFamily="34" charset="-120"/>
               </a:rPr>
-              <a:t> toàn</a:t>
-            </a:r>
-            <a:r>
-              <a:rPr lang="en-US" sz="2700" dirty="0" spc="-7" kern="0">
+              <a:t> bộ</a:t>
+            </a:r>
+            <a:r>
+              <a:rPr lang="en-US" sz="2700" dirty="0" spc="0" kern="0">
                 <a:solidFill>
                   <a:srgbClr val="14161C"/>
                 </a:solidFill>
@@ -13238,21 +13260,10 @@
                 <a:ea typeface="Be Vietnam Pro" pitchFamily="34" charset="-122"/>
                 <a:cs typeface="Be Vietnam Pro" pitchFamily="34" charset="-120"/>
               </a:rPr>
-              <a:t> bộ</a:t>
-            </a:r>
-            <a:r>
-              <a:rPr lang="en-US" sz="2700" dirty="0" spc="-1" kern="0">
-                <a:solidFill>
-                  <a:srgbClr val="14161C"/>
-                </a:solidFill>
-                <a:latin typeface="Be Vietnam Pro" pitchFamily="34" charset="0"/>
-                <a:ea typeface="Be Vietnam Pro" pitchFamily="34" charset="-122"/>
-                <a:cs typeface="Be Vietnam Pro" pitchFamily="34" charset="-120"/>
-              </a:rPr>
               <a:t> lịch</a:t>
             </a:r>
             <a:r>
-              <a:rPr lang="en-US" sz="2700" dirty="0" spc="-3" kern="0">
+              <a:rPr lang="en-US" sz="2700" dirty="0" spc="-4" kern="0">
                 <a:solidFill>
                   <a:srgbClr val="14161C"/>
                 </a:solidFill>

</xml_diff>